<commit_message>
data: re-run run_2026-06-26_001 under 700-HCP holdout scope (new result, narrative, deck)
</commit_message>
<xml_diff>
--- a/output/run_2026-06-26_001/deck.pptx
+++ b/output/run_2026-06-26_001/deck.pptx
@@ -3288,7 +3288,7 @@
                 </a:solidFill>
                 <a:latin typeface="Montserrat Medium"/>
               </a:rPr>
-              <a:t>1,040 Crohn's HCPs Narrow to a 43-Prescriber STELARA Switch List</a:t>
+              <a:t>700 Crohn's HCPs Narrow to a 30-Prescriber STELARA Switch List</a:t>
             </a:r>
           </a:p>
         </p:txBody>
@@ -4023,7 +4023,7 @@
                 </a:solidFill>
                 <a:latin typeface="Montserrat Medium"/>
               </a:rPr>
-              <a:t>1,040</a:t>
+              <a:t>700</a:t>
             </a:r>
           </a:p>
         </p:txBody>
@@ -4147,7 +4147,7 @@
                 </a:solidFill>
                 <a:latin typeface="Montserrat Medium"/>
               </a:rPr>
-              <a:t>670  ·  64%</a:t>
+              <a:t>456  ·  65%</a:t>
             </a:r>
           </a:p>
         </p:txBody>
@@ -4271,7 +4271,7 @@
                 </a:solidFill>
                 <a:latin typeface="Montserrat Medium"/>
               </a:rPr>
-              <a:t>370  ·  36%</a:t>
+              <a:t>244  ·  35%</a:t>
             </a:r>
           </a:p>
         </p:txBody>
@@ -4481,7 +4481,7 @@
                 </a:solidFill>
                 <a:latin typeface="Montserrat Medium"/>
               </a:rPr>
-              <a:t>627</a:t>
+              <a:t>426</a:t>
             </a:r>
           </a:p>
         </p:txBody>
@@ -4622,7 +4622,7 @@
         <p:spPr>
           <a:xfrm>
             <a:off x="4855464" y="3090672"/>
-            <a:ext cx="54981" cy="68580"/>
+            <a:ext cx="52911" cy="68580"/>
           </a:xfrm>
           <a:prstGeom prst="rect">
             <a:avLst/>
@@ -4691,7 +4691,7 @@
                 </a:solidFill>
                 <a:latin typeface="Montserrat Medium"/>
               </a:rPr>
-              <a:t>26</a:t>
+              <a:t>17</a:t>
             </a:r>
           </a:p>
         </p:txBody>
@@ -4901,7 +4901,7 @@
                 </a:solidFill>
                 <a:latin typeface="Montserrat Medium"/>
               </a:rPr>
-              <a:t>17</a:t>
+              <a:t>13</a:t>
             </a:r>
           </a:p>
         </p:txBody>
@@ -5042,7 +5042,7 @@
         <p:spPr>
           <a:xfrm>
             <a:off x="4855464" y="4718304"/>
-            <a:ext cx="776073" cy="68580"/>
+            <a:ext cx="756312" cy="68580"/>
           </a:xfrm>
           <a:prstGeom prst="rect">
             <a:avLst/>
@@ -5111,7 +5111,7 @@
                 </a:solidFill>
                 <a:latin typeface="Montserrat Medium"/>
               </a:rPr>
-              <a:t>367</a:t>
+              <a:t>243</a:t>
             </a:r>
           </a:p>
         </p:txBody>
@@ -5321,7 +5321,7 @@
                 </a:solidFill>
                 <a:latin typeface="Montserrat Medium"/>
               </a:rPr>
-              <a:t>3</a:t>
+              <a:t>1</a:t>
             </a:r>
           </a:p>
         </p:txBody>
@@ -5580,7 +5580,7 @@
                 </a:solidFill>
                 <a:latin typeface="Montserrat Medium"/>
               </a:rPr>
-              <a:t>627 are silent</a:t>
+              <a:t>426 are silent</a:t>
             </a:r>
           </a:p>
         </p:txBody>
@@ -5834,7 +5834,7 @@
                 </a:solidFill>
                 <a:latin typeface="Montserrat Medium"/>
               </a:rPr>
-              <a:t>43 active STELARA prescribers</a:t>
+              <a:t>30 active STELARA prescribers</a:t>
             </a:r>
           </a:p>
         </p:txBody>
@@ -5873,7 +5873,7 @@
                 </a:solidFill>
                 <a:latin typeface="Roboto"/>
               </a:rPr>
-              <a:t>26 write STELARA only and 17 write both but lean STELARA. The concentrated, high-yield conversion target.</a:t>
+              <a:t>17 write STELARA only and 13 write both but lean STELARA. The concentrated, high-yield conversion target.</a:t>
             </a:r>
           </a:p>
         </p:txBody>
@@ -6127,7 +6127,7 @@
                 </a:solidFill>
                 <a:latin typeface="Roboto"/>
               </a:rPr>
-              <a:t>666 vs 49 Crohn's NBRx (13.6x). Among Non-Holdouts the priority is retention, not conversion.</a:t>
+              <a:t>436 vs 32 Crohn's NBRx (13.6x). Among Non-Holdouts the priority is retention, not conversion.</a:t>
             </a:r>
           </a:p>
         </p:txBody>
@@ -6263,7 +6263,7 @@
                 </a:solidFill>
                 <a:latin typeface="Roboto"/>
               </a:rPr>
-              <a:t>Put conversion effort on the 43 active STELARA-leaning prescribers; the 370 Non-Holdouts are a retention play.</a:t>
+              <a:t>Put conversion effort on the 30 active STELARA-leaning prescribers; the 244 Non-Holdouts are a retention play.</a:t>
             </a:r>
           </a:p>
         </p:txBody>

</xml_diff>